<commit_message>
Corrected the word AROC with AUC-ROC to make it consistent with chapter 6 and 7. Eliminated figures that were not included in the thesis
</commit_message>
<xml_diff>
--- a/chapter_05/figures/rainfall_based_ff_verif_breakdown_scores_roc_1rp.pptx
+++ b/chapter_05/figures/rainfall_based_ff_verif_breakdown_scores_roc_1rp.pptx
@@ -115,7 +115,7 @@
 <file path=ppt/revisionInfo.xml><?xml version="1.0" encoding="utf-8"?>
 <p1510:revInfo xmlns:a="http://schemas.openxmlformats.org/drawingml/2006/main" xmlns:r="http://schemas.openxmlformats.org/officeDocument/2006/relationships" xmlns:p1510="http://schemas.microsoft.com/office/powerpoint/2015/10/main">
   <p1510:revLst>
-    <p1510:client id="{E0DE9FFC-A79A-49F3-A9EA-98D7366CA706}" v="33" dt="2025-05-24T17:49:35.810"/>
+    <p1510:client id="{D7552E4F-FEA4-454C-BBB1-9F45DF71D23B}" v="1" dt="2026-01-26T21:43:28.450"/>
   </p1510:revLst>
 </p1510:revInfo>
 </file>
@@ -123,745 +123,66 @@
 <file path=ppt/changesInfos/changesInfo1.xml><?xml version="1.0" encoding="utf-8"?>
 <pc:chgInfo xmlns:a="http://schemas.openxmlformats.org/drawingml/2006/main" xmlns:r="http://schemas.openxmlformats.org/officeDocument/2006/relationships" xmlns:ac="http://schemas.microsoft.com/office/drawing/2013/main/command" xmlns:pc="http://schemas.microsoft.com/office/powerpoint/2013/main/command">
   <pc:docChgLst>
-    <pc:chgData name="Fatima Pillosu" userId="a6295d4dc9e22643" providerId="LiveId" clId="{E0DE9FFC-A79A-49F3-A9EA-98D7366CA706}"/>
-    <pc:docChg chg="undo custSel addSld delSld modSld">
-      <pc:chgData name="Fatima Pillosu" userId="a6295d4dc9e22643" providerId="LiveId" clId="{E0DE9FFC-A79A-49F3-A9EA-98D7366CA706}" dt="2025-05-24T17:49:45.139" v="1294" actId="1037"/>
+    <pc:chgData name="Fatima Pillosu" userId="a6295d4dc9e22643" providerId="LiveId" clId="{87453732-75AC-4426-B5D3-B7C69C2D4F54}"/>
+    <pc:docChg chg="custSel modSld">
+      <pc:chgData name="Fatima Pillosu" userId="a6295d4dc9e22643" providerId="LiveId" clId="{87453732-75AC-4426-B5D3-B7C69C2D4F54}" dt="2026-01-26T21:43:49.868" v="8" actId="1036"/>
       <pc:docMkLst>
         <pc:docMk/>
       </pc:docMkLst>
-      <pc:sldChg chg="addSp delSp modSp mod">
-        <pc:chgData name="Fatima Pillosu" userId="a6295d4dc9e22643" providerId="LiveId" clId="{E0DE9FFC-A79A-49F3-A9EA-98D7366CA706}" dt="2025-05-24T17:49:45.139" v="1294" actId="1037"/>
+      <pc:sldChg chg="modSp mod">
+        <pc:chgData name="Fatima Pillosu" userId="a6295d4dc9e22643" providerId="LiveId" clId="{87453732-75AC-4426-B5D3-B7C69C2D4F54}" dt="2026-01-26T21:43:49.868" v="8" actId="1036"/>
         <pc:sldMkLst>
           <pc:docMk/>
           <pc:sldMk cId="2001934226" sldId="256"/>
         </pc:sldMkLst>
-        <pc:spChg chg="add del mod">
-          <ac:chgData name="Fatima Pillosu" userId="a6295d4dc9e22643" providerId="LiveId" clId="{E0DE9FFC-A79A-49F3-A9EA-98D7366CA706}" dt="2025-05-24T17:49:23.420" v="1275" actId="21"/>
-          <ac:spMkLst>
-            <pc:docMk/>
-            <pc:sldMk cId="2001934226" sldId="256"/>
-            <ac:spMk id="2" creationId="{1439338B-2360-F0B9-54B0-E0E8A3F764B5}"/>
-          </ac:spMkLst>
-        </pc:spChg>
-        <pc:spChg chg="add del">
-          <ac:chgData name="Fatima Pillosu" userId="a6295d4dc9e22643" providerId="LiveId" clId="{E0DE9FFC-A79A-49F3-A9EA-98D7366CA706}" dt="2025-05-24T17:49:22.002" v="1274" actId="478"/>
-          <ac:spMkLst>
-            <pc:docMk/>
-            <pc:sldMk cId="2001934226" sldId="256"/>
-            <ac:spMk id="3" creationId="{007DAE7C-127E-6D61-8838-C5B3AEB4EFC9}"/>
-          </ac:spMkLst>
-        </pc:spChg>
-        <pc:spChg chg="add del mod">
-          <ac:chgData name="Fatima Pillosu" userId="a6295d4dc9e22643" providerId="LiveId" clId="{E0DE9FFC-A79A-49F3-A9EA-98D7366CA706}" dt="2025-05-24T17:29:08.149" v="1024" actId="478"/>
-          <ac:spMkLst>
-            <pc:docMk/>
-            <pc:sldMk cId="2001934226" sldId="256"/>
-            <ac:spMk id="3" creationId="{157B2B02-C3BD-211E-1A63-17A6B076F3B3}"/>
-          </ac:spMkLst>
-        </pc:spChg>
-        <pc:spChg chg="add del mod">
-          <ac:chgData name="Fatima Pillosu" userId="a6295d4dc9e22643" providerId="LiveId" clId="{E0DE9FFC-A79A-49F3-A9EA-98D7366CA706}" dt="2025-05-24T17:31:14.864" v="1095" actId="478"/>
-          <ac:spMkLst>
-            <pc:docMk/>
-            <pc:sldMk cId="2001934226" sldId="256"/>
-            <ac:spMk id="4" creationId="{BC3CF038-561F-BC84-91B6-A09983A80546}"/>
-          </ac:spMkLst>
-        </pc:spChg>
-        <pc:spChg chg="add del mod">
-          <ac:chgData name="Fatima Pillosu" userId="a6295d4dc9e22643" providerId="LiveId" clId="{E0DE9FFC-A79A-49F3-A9EA-98D7366CA706}" dt="2025-05-24T17:31:13.692" v="1094" actId="478"/>
-          <ac:spMkLst>
-            <pc:docMk/>
-            <pc:sldMk cId="2001934226" sldId="256"/>
-            <ac:spMk id="5" creationId="{D67A9C74-C781-FB85-1261-C25CBA0ED947}"/>
-          </ac:spMkLst>
-        </pc:spChg>
-        <pc:spChg chg="add del mod">
-          <ac:chgData name="Fatima Pillosu" userId="a6295d4dc9e22643" providerId="LiveId" clId="{E0DE9FFC-A79A-49F3-A9EA-98D7366CA706}" dt="2025-05-24T17:31:12.645" v="1093" actId="478"/>
-          <ac:spMkLst>
-            <pc:docMk/>
-            <pc:sldMk cId="2001934226" sldId="256"/>
-            <ac:spMk id="8" creationId="{2E5BF72F-D121-7735-FB51-3A65FBC91D16}"/>
-          </ac:spMkLst>
-        </pc:spChg>
-        <pc:spChg chg="add del mod">
-          <ac:chgData name="Fatima Pillosu" userId="a6295d4dc9e22643" providerId="LiveId" clId="{E0DE9FFC-A79A-49F3-A9EA-98D7366CA706}" dt="2025-05-24T17:49:23.420" v="1275" actId="21"/>
-          <ac:spMkLst>
-            <pc:docMk/>
-            <pc:sldMk cId="2001934226" sldId="256"/>
-            <ac:spMk id="10" creationId="{8B1F5955-FCB9-F344-7FF7-DF879384E574}"/>
-          </ac:spMkLst>
-        </pc:spChg>
-        <pc:spChg chg="add del mod">
-          <ac:chgData name="Fatima Pillosu" userId="a6295d4dc9e22643" providerId="LiveId" clId="{E0DE9FFC-A79A-49F3-A9EA-98D7366CA706}" dt="2025-05-24T17:49:23.420" v="1275" actId="21"/>
-          <ac:spMkLst>
-            <pc:docMk/>
-            <pc:sldMk cId="2001934226" sldId="256"/>
-            <ac:spMk id="11" creationId="{A2A68CE5-3663-E3BA-5B16-FF1EBD5CAD67}"/>
-          </ac:spMkLst>
-        </pc:spChg>
-        <pc:spChg chg="add del mod">
-          <ac:chgData name="Fatima Pillosu" userId="a6295d4dc9e22643" providerId="LiveId" clId="{E0DE9FFC-A79A-49F3-A9EA-98D7366CA706}" dt="2025-05-24T17:49:23.420" v="1275" actId="21"/>
-          <ac:spMkLst>
-            <pc:docMk/>
-            <pc:sldMk cId="2001934226" sldId="256"/>
-            <ac:spMk id="13" creationId="{0DD473FB-E495-B2CC-B0FF-A62B16673603}"/>
-          </ac:spMkLst>
-        </pc:spChg>
-        <pc:spChg chg="add del mod">
-          <ac:chgData name="Fatima Pillosu" userId="a6295d4dc9e22643" providerId="LiveId" clId="{E0DE9FFC-A79A-49F3-A9EA-98D7366CA706}" dt="2025-05-24T17:49:23.420" v="1275" actId="21"/>
-          <ac:spMkLst>
-            <pc:docMk/>
-            <pc:sldMk cId="2001934226" sldId="256"/>
-            <ac:spMk id="14" creationId="{44BA3302-BB3A-42E9-5A33-833C023D5C47}"/>
-          </ac:spMkLst>
-        </pc:spChg>
-        <pc:spChg chg="add del mod">
-          <ac:chgData name="Fatima Pillosu" userId="a6295d4dc9e22643" providerId="LiveId" clId="{E0DE9FFC-A79A-49F3-A9EA-98D7366CA706}" dt="2025-05-24T17:49:23.420" v="1275" actId="21"/>
-          <ac:spMkLst>
-            <pc:docMk/>
-            <pc:sldMk cId="2001934226" sldId="256"/>
-            <ac:spMk id="16" creationId="{FE152A2A-430B-C523-E1E8-2692C774555F}"/>
-          </ac:spMkLst>
-        </pc:spChg>
-        <pc:spChg chg="add del mod">
-          <ac:chgData name="Fatima Pillosu" userId="a6295d4dc9e22643" providerId="LiveId" clId="{E0DE9FFC-A79A-49F3-A9EA-98D7366CA706}" dt="2025-05-24T17:49:23.420" v="1275" actId="21"/>
-          <ac:spMkLst>
-            <pc:docMk/>
-            <pc:sldMk cId="2001934226" sldId="256"/>
-            <ac:spMk id="17" creationId="{7D251682-B46D-DC7E-8C5E-59DFF1C27261}"/>
-          </ac:spMkLst>
-        </pc:spChg>
-        <pc:spChg chg="add del mod">
-          <ac:chgData name="Fatima Pillosu" userId="a6295d4dc9e22643" providerId="LiveId" clId="{E0DE9FFC-A79A-49F3-A9EA-98D7366CA706}" dt="2025-05-24T17:49:23.420" v="1275" actId="21"/>
-          <ac:spMkLst>
-            <pc:docMk/>
-            <pc:sldMk cId="2001934226" sldId="256"/>
-            <ac:spMk id="18" creationId="{18F79773-A305-6943-D6AB-6A9BB374B2B4}"/>
-          </ac:spMkLst>
-        </pc:spChg>
-        <pc:spChg chg="add del mod">
-          <ac:chgData name="Fatima Pillosu" userId="a6295d4dc9e22643" providerId="LiveId" clId="{E0DE9FFC-A79A-49F3-A9EA-98D7366CA706}" dt="2025-05-24T17:49:23.420" v="1275" actId="21"/>
-          <ac:spMkLst>
-            <pc:docMk/>
-            <pc:sldMk cId="2001934226" sldId="256"/>
-            <ac:spMk id="19" creationId="{812B84FE-6FFF-9B2B-74C3-F9216FC6BFC1}"/>
-          </ac:spMkLst>
-        </pc:spChg>
-        <pc:spChg chg="add del mod">
-          <ac:chgData name="Fatima Pillosu" userId="a6295d4dc9e22643" providerId="LiveId" clId="{E0DE9FFC-A79A-49F3-A9EA-98D7366CA706}" dt="2025-05-22T22:39:29.506" v="412" actId="478"/>
-          <ac:spMkLst>
-            <pc:docMk/>
-            <pc:sldMk cId="2001934226" sldId="256"/>
-            <ac:spMk id="20" creationId="{B190699C-CD78-67B2-01EB-B98F05AD881F}"/>
-          </ac:spMkLst>
-        </pc:spChg>
-        <pc:spChg chg="add del mod">
-          <ac:chgData name="Fatima Pillosu" userId="a6295d4dc9e22643" providerId="LiveId" clId="{E0DE9FFC-A79A-49F3-A9EA-98D7366CA706}" dt="2025-05-24T17:24:35.889" v="861" actId="478"/>
-          <ac:spMkLst>
-            <pc:docMk/>
-            <pc:sldMk cId="2001934226" sldId="256"/>
-            <ac:spMk id="21" creationId="{0284A2DC-04F5-0D2C-8A57-01740B49A0AD}"/>
-          </ac:spMkLst>
-        </pc:spChg>
-        <pc:spChg chg="add del mod">
-          <ac:chgData name="Fatima Pillosu" userId="a6295d4dc9e22643" providerId="LiveId" clId="{E0DE9FFC-A79A-49F3-A9EA-98D7366CA706}" dt="2025-05-24T17:24:39.696" v="862" actId="478"/>
-          <ac:spMkLst>
-            <pc:docMk/>
-            <pc:sldMk cId="2001934226" sldId="256"/>
-            <ac:spMk id="22" creationId="{7792FD3C-224E-D659-A131-B255E8E96E52}"/>
-          </ac:spMkLst>
-        </pc:spChg>
-        <pc:spChg chg="add del mod">
-          <ac:chgData name="Fatima Pillosu" userId="a6295d4dc9e22643" providerId="LiveId" clId="{E0DE9FFC-A79A-49F3-A9EA-98D7366CA706}" dt="2025-05-24T17:24:40.855" v="863" actId="478"/>
-          <ac:spMkLst>
-            <pc:docMk/>
-            <pc:sldMk cId="2001934226" sldId="256"/>
-            <ac:spMk id="23" creationId="{F19462D0-2710-AA91-1CCF-483BA08755F9}"/>
-          </ac:spMkLst>
-        </pc:spChg>
-        <pc:spChg chg="add del mod">
-          <ac:chgData name="Fatima Pillosu" userId="a6295d4dc9e22643" providerId="LiveId" clId="{E0DE9FFC-A79A-49F3-A9EA-98D7366CA706}" dt="2025-05-24T17:24:44.672" v="865" actId="478"/>
-          <ac:spMkLst>
-            <pc:docMk/>
-            <pc:sldMk cId="2001934226" sldId="256"/>
-            <ac:spMk id="24" creationId="{728394F9-CAEC-DD34-1C7D-BCD4BEC3F436}"/>
-          </ac:spMkLst>
-        </pc:spChg>
-        <pc:spChg chg="add mod">
-          <ac:chgData name="Fatima Pillosu" userId="a6295d4dc9e22643" providerId="LiveId" clId="{E0DE9FFC-A79A-49F3-A9EA-98D7366CA706}" dt="2025-05-24T17:49:35.810" v="1276"/>
-          <ac:spMkLst>
-            <pc:docMk/>
-            <pc:sldMk cId="2001934226" sldId="256"/>
-            <ac:spMk id="24" creationId="{7D251682-B46D-DC7E-8C5E-59DFF1C27261}"/>
-          </ac:spMkLst>
-        </pc:spChg>
-        <pc:spChg chg="add mod">
-          <ac:chgData name="Fatima Pillosu" userId="a6295d4dc9e22643" providerId="LiveId" clId="{E0DE9FFC-A79A-49F3-A9EA-98D7366CA706}" dt="2025-05-24T17:49:35.810" v="1276"/>
+        <pc:spChg chg="mod">
+          <ac:chgData name="Fatima Pillosu" userId="a6295d4dc9e22643" providerId="LiveId" clId="{87453732-75AC-4426-B5D3-B7C69C2D4F54}" dt="2026-01-26T21:43:49.868" v="8" actId="1036"/>
           <ac:spMkLst>
             <pc:docMk/>
             <pc:sldMk cId="2001934226" sldId="256"/>
             <ac:spMk id="25" creationId="{18F79773-A305-6943-D6AB-6A9BB374B2B4}"/>
           </ac:spMkLst>
         </pc:spChg>
-        <pc:spChg chg="add del mod">
-          <ac:chgData name="Fatima Pillosu" userId="a6295d4dc9e22643" providerId="LiveId" clId="{E0DE9FFC-A79A-49F3-A9EA-98D7366CA706}" dt="2025-05-24T17:24:43.571" v="864" actId="478"/>
-          <ac:spMkLst>
-            <pc:docMk/>
-            <pc:sldMk cId="2001934226" sldId="256"/>
-            <ac:spMk id="25" creationId="{FC832C13-787F-2152-898E-AA680DE9C99E}"/>
-          </ac:spMkLst>
-        </pc:spChg>
-        <pc:spChg chg="add del mod">
-          <ac:chgData name="Fatima Pillosu" userId="a6295d4dc9e22643" providerId="LiveId" clId="{E0DE9FFC-A79A-49F3-A9EA-98D7366CA706}" dt="2025-05-24T17:49:23.420" v="1275" actId="21"/>
-          <ac:spMkLst>
-            <pc:docMk/>
-            <pc:sldMk cId="2001934226" sldId="256"/>
-            <ac:spMk id="26" creationId="{46667C36-0CBE-9755-7F89-8AACC8E51FA9}"/>
-          </ac:spMkLst>
-        </pc:spChg>
-        <pc:spChg chg="add del mod">
-          <ac:chgData name="Fatima Pillosu" userId="a6295d4dc9e22643" providerId="LiveId" clId="{E0DE9FFC-A79A-49F3-A9EA-98D7366CA706}" dt="2025-05-24T17:49:23.420" v="1275" actId="21"/>
-          <ac:spMkLst>
-            <pc:docMk/>
-            <pc:sldMk cId="2001934226" sldId="256"/>
-            <ac:spMk id="27" creationId="{F71E61F0-9840-9B7F-30F2-30B65396312F}"/>
-          </ac:spMkLst>
-        </pc:spChg>
-        <pc:spChg chg="add del mod">
-          <ac:chgData name="Fatima Pillosu" userId="a6295d4dc9e22643" providerId="LiveId" clId="{E0DE9FFC-A79A-49F3-A9EA-98D7366CA706}" dt="2025-05-24T17:49:23.420" v="1275" actId="21"/>
-          <ac:spMkLst>
-            <pc:docMk/>
-            <pc:sldMk cId="2001934226" sldId="256"/>
-            <ac:spMk id="28" creationId="{CF1C25AE-D652-11A5-B5EC-F8165BE323FC}"/>
-          </ac:spMkLst>
-        </pc:spChg>
-        <pc:spChg chg="add del mod">
-          <ac:chgData name="Fatima Pillosu" userId="a6295d4dc9e22643" providerId="LiveId" clId="{E0DE9FFC-A79A-49F3-A9EA-98D7366CA706}" dt="2025-05-24T17:49:23.420" v="1275" actId="21"/>
-          <ac:spMkLst>
-            <pc:docMk/>
-            <pc:sldMk cId="2001934226" sldId="256"/>
-            <ac:spMk id="29" creationId="{31F73A1B-3ADC-F2FE-4134-96AE95176977}"/>
-          </ac:spMkLst>
-        </pc:spChg>
-        <pc:spChg chg="add del mod">
-          <ac:chgData name="Fatima Pillosu" userId="a6295d4dc9e22643" providerId="LiveId" clId="{E0DE9FFC-A79A-49F3-A9EA-98D7366CA706}" dt="2025-05-24T17:49:23.420" v="1275" actId="21"/>
-          <ac:spMkLst>
-            <pc:docMk/>
-            <pc:sldMk cId="2001934226" sldId="256"/>
-            <ac:spMk id="30" creationId="{9CAEBC89-740E-B6AE-1664-60181017FDA9}"/>
-          </ac:spMkLst>
-        </pc:spChg>
-        <pc:spChg chg="add del mod">
-          <ac:chgData name="Fatima Pillosu" userId="a6295d4dc9e22643" providerId="LiveId" clId="{E0DE9FFC-A79A-49F3-A9EA-98D7366CA706}" dt="2025-05-24T17:49:23.420" v="1275" actId="21"/>
-          <ac:spMkLst>
-            <pc:docMk/>
-            <pc:sldMk cId="2001934226" sldId="256"/>
-            <ac:spMk id="31" creationId="{A915B4F4-9555-239A-6644-707B5F75353A}"/>
-          </ac:spMkLst>
-        </pc:spChg>
-        <pc:spChg chg="add del mod">
-          <ac:chgData name="Fatima Pillosu" userId="a6295d4dc9e22643" providerId="LiveId" clId="{E0DE9FFC-A79A-49F3-A9EA-98D7366CA706}" dt="2025-05-24T17:49:23.420" v="1275" actId="21"/>
-          <ac:spMkLst>
-            <pc:docMk/>
-            <pc:sldMk cId="2001934226" sldId="256"/>
-            <ac:spMk id="33" creationId="{BDE5C9A9-3189-D01F-D799-FE5E444982DC}"/>
-          </ac:spMkLst>
-        </pc:spChg>
-        <pc:spChg chg="add mod">
-          <ac:chgData name="Fatima Pillosu" userId="a6295d4dc9e22643" providerId="LiveId" clId="{E0DE9FFC-A79A-49F3-A9EA-98D7366CA706}" dt="2025-05-24T17:49:35.810" v="1276"/>
-          <ac:spMkLst>
-            <pc:docMk/>
-            <pc:sldMk cId="2001934226" sldId="256"/>
-            <ac:spMk id="34" creationId="{1439338B-2360-F0B9-54B0-E0E8A3F764B5}"/>
-          </ac:spMkLst>
-        </pc:spChg>
-        <pc:spChg chg="add mod">
-          <ac:chgData name="Fatima Pillosu" userId="a6295d4dc9e22643" providerId="LiveId" clId="{E0DE9FFC-A79A-49F3-A9EA-98D7366CA706}" dt="2025-05-24T17:49:35.810" v="1276"/>
+        <pc:spChg chg="mod">
+          <ac:chgData name="Fatima Pillosu" userId="a6295d4dc9e22643" providerId="LiveId" clId="{87453732-75AC-4426-B5D3-B7C69C2D4F54}" dt="2026-01-26T21:43:49.868" v="8" actId="1036"/>
           <ac:spMkLst>
             <pc:docMk/>
             <pc:sldMk cId="2001934226" sldId="256"/>
             <ac:spMk id="35" creationId="{8B1F5955-FCB9-F344-7FF7-DF879384E574}"/>
           </ac:spMkLst>
         </pc:spChg>
-        <pc:spChg chg="add mod">
-          <ac:chgData name="Fatima Pillosu" userId="a6295d4dc9e22643" providerId="LiveId" clId="{E0DE9FFC-A79A-49F3-A9EA-98D7366CA706}" dt="2025-05-24T17:49:35.810" v="1276"/>
+        <pc:spChg chg="mod">
+          <ac:chgData name="Fatima Pillosu" userId="a6295d4dc9e22643" providerId="LiveId" clId="{87453732-75AC-4426-B5D3-B7C69C2D4F54}" dt="2026-01-26T21:43:49.868" v="8" actId="1036"/>
           <ac:spMkLst>
             <pc:docMk/>
             <pc:sldMk cId="2001934226" sldId="256"/>
             <ac:spMk id="36" creationId="{A2A68CE5-3663-E3BA-5B16-FF1EBD5CAD67}"/>
           </ac:spMkLst>
         </pc:spChg>
-        <pc:spChg chg="add mod">
-          <ac:chgData name="Fatima Pillosu" userId="a6295d4dc9e22643" providerId="LiveId" clId="{E0DE9FFC-A79A-49F3-A9EA-98D7366CA706}" dt="2025-05-24T17:49:35.810" v="1276"/>
+        <pc:spChg chg="mod">
+          <ac:chgData name="Fatima Pillosu" userId="a6295d4dc9e22643" providerId="LiveId" clId="{87453732-75AC-4426-B5D3-B7C69C2D4F54}" dt="2026-01-26T21:43:49.868" v="8" actId="1036"/>
           <ac:spMkLst>
             <pc:docMk/>
             <pc:sldMk cId="2001934226" sldId="256"/>
             <ac:spMk id="37" creationId="{0DD473FB-E495-B2CC-B0FF-A62B16673603}"/>
           </ac:spMkLst>
         </pc:spChg>
-        <pc:spChg chg="add mod">
-          <ac:chgData name="Fatima Pillosu" userId="a6295d4dc9e22643" providerId="LiveId" clId="{E0DE9FFC-A79A-49F3-A9EA-98D7366CA706}" dt="2025-05-24T17:49:35.810" v="1276"/>
+        <pc:spChg chg="mod">
+          <ac:chgData name="Fatima Pillosu" userId="a6295d4dc9e22643" providerId="LiveId" clId="{87453732-75AC-4426-B5D3-B7C69C2D4F54}" dt="2026-01-26T21:43:49.868" v="8" actId="1036"/>
           <ac:spMkLst>
             <pc:docMk/>
             <pc:sldMk cId="2001934226" sldId="256"/>
             <ac:spMk id="38" creationId="{44BA3302-BB3A-42E9-5A33-833C023D5C47}"/>
           </ac:spMkLst>
         </pc:spChg>
-        <pc:spChg chg="add mod">
-          <ac:chgData name="Fatima Pillosu" userId="a6295d4dc9e22643" providerId="LiveId" clId="{E0DE9FFC-A79A-49F3-A9EA-98D7366CA706}" dt="2025-05-24T17:49:35.810" v="1276"/>
+        <pc:spChg chg="mod">
+          <ac:chgData name="Fatima Pillosu" userId="a6295d4dc9e22643" providerId="LiveId" clId="{87453732-75AC-4426-B5D3-B7C69C2D4F54}" dt="2026-01-26T21:43:49.868" v="8" actId="1036"/>
           <ac:spMkLst>
             <pc:docMk/>
             <pc:sldMk cId="2001934226" sldId="256"/>
             <ac:spMk id="39" creationId="{FE152A2A-430B-C523-E1E8-2692C774555F}"/>
           </ac:spMkLst>
         </pc:spChg>
-        <pc:spChg chg="add mod">
-          <ac:chgData name="Fatima Pillosu" userId="a6295d4dc9e22643" providerId="LiveId" clId="{E0DE9FFC-A79A-49F3-A9EA-98D7366CA706}" dt="2025-05-24T17:49:35.810" v="1276"/>
-          <ac:spMkLst>
-            <pc:docMk/>
-            <pc:sldMk cId="2001934226" sldId="256"/>
-            <ac:spMk id="40" creationId="{812B84FE-6FFF-9B2B-74C3-F9216FC6BFC1}"/>
-          </ac:spMkLst>
-        </pc:spChg>
-        <pc:spChg chg="add mod">
-          <ac:chgData name="Fatima Pillosu" userId="a6295d4dc9e22643" providerId="LiveId" clId="{E0DE9FFC-A79A-49F3-A9EA-98D7366CA706}" dt="2025-05-24T17:49:35.810" v="1276"/>
-          <ac:spMkLst>
-            <pc:docMk/>
-            <pc:sldMk cId="2001934226" sldId="256"/>
-            <ac:spMk id="41" creationId="{46667C36-0CBE-9755-7F89-8AACC8E51FA9}"/>
-          </ac:spMkLst>
-        </pc:spChg>
-        <pc:spChg chg="add mod">
-          <ac:chgData name="Fatima Pillosu" userId="a6295d4dc9e22643" providerId="LiveId" clId="{E0DE9FFC-A79A-49F3-A9EA-98D7366CA706}" dt="2025-05-24T17:49:35.810" v="1276"/>
-          <ac:spMkLst>
-            <pc:docMk/>
-            <pc:sldMk cId="2001934226" sldId="256"/>
-            <ac:spMk id="42" creationId="{F71E61F0-9840-9B7F-30F2-30B65396312F}"/>
-          </ac:spMkLst>
-        </pc:spChg>
-        <pc:spChg chg="add mod">
-          <ac:chgData name="Fatima Pillosu" userId="a6295d4dc9e22643" providerId="LiveId" clId="{E0DE9FFC-A79A-49F3-A9EA-98D7366CA706}" dt="2025-05-24T17:49:35.810" v="1276"/>
-          <ac:spMkLst>
-            <pc:docMk/>
-            <pc:sldMk cId="2001934226" sldId="256"/>
-            <ac:spMk id="43" creationId="{CF1C25AE-D652-11A5-B5EC-F8165BE323FC}"/>
-          </ac:spMkLst>
-        </pc:spChg>
-        <pc:spChg chg="add mod">
-          <ac:chgData name="Fatima Pillosu" userId="a6295d4dc9e22643" providerId="LiveId" clId="{E0DE9FFC-A79A-49F3-A9EA-98D7366CA706}" dt="2025-05-24T17:49:35.810" v="1276"/>
-          <ac:spMkLst>
-            <pc:docMk/>
-            <pc:sldMk cId="2001934226" sldId="256"/>
-            <ac:spMk id="44" creationId="{31F73A1B-3ADC-F2FE-4134-96AE95176977}"/>
-          </ac:spMkLst>
-        </pc:spChg>
-        <pc:spChg chg="add mod">
-          <ac:chgData name="Fatima Pillosu" userId="a6295d4dc9e22643" providerId="LiveId" clId="{E0DE9FFC-A79A-49F3-A9EA-98D7366CA706}" dt="2025-05-24T17:49:45.139" v="1294" actId="1037"/>
-          <ac:spMkLst>
-            <pc:docMk/>
-            <pc:sldMk cId="2001934226" sldId="256"/>
-            <ac:spMk id="45" creationId="{9CAEBC89-740E-B6AE-1664-60181017FDA9}"/>
-          </ac:spMkLst>
-        </pc:spChg>
-        <pc:spChg chg="add mod">
-          <ac:chgData name="Fatima Pillosu" userId="a6295d4dc9e22643" providerId="LiveId" clId="{E0DE9FFC-A79A-49F3-A9EA-98D7366CA706}" dt="2025-05-24T17:49:45.139" v="1294" actId="1037"/>
-          <ac:spMkLst>
-            <pc:docMk/>
-            <pc:sldMk cId="2001934226" sldId="256"/>
-            <ac:spMk id="46" creationId="{A915B4F4-9555-239A-6644-707B5F75353A}"/>
-          </ac:spMkLst>
-        </pc:spChg>
-        <pc:spChg chg="add mod">
-          <ac:chgData name="Fatima Pillosu" userId="a6295d4dc9e22643" providerId="LiveId" clId="{E0DE9FFC-A79A-49F3-A9EA-98D7366CA706}" dt="2025-05-24T17:49:45.139" v="1294" actId="1037"/>
-          <ac:spMkLst>
-            <pc:docMk/>
-            <pc:sldMk cId="2001934226" sldId="256"/>
-            <ac:spMk id="48" creationId="{BDE5C9A9-3189-D01F-D799-FE5E444982DC}"/>
-          </ac:spMkLst>
-        </pc:spChg>
-        <pc:picChg chg="add del mod modCrop">
-          <ac:chgData name="Fatima Pillosu" userId="a6295d4dc9e22643" providerId="LiveId" clId="{E0DE9FFC-A79A-49F3-A9EA-98D7366CA706}" dt="2025-05-24T16:28:39.043" v="572" actId="478"/>
-          <ac:picMkLst>
-            <pc:docMk/>
-            <pc:sldMk cId="2001934226" sldId="256"/>
-            <ac:picMk id="3" creationId="{654FB377-4601-2239-3475-0294C0DABA0E}"/>
-          </ac:picMkLst>
-        </pc:picChg>
-        <pc:picChg chg="add del mod">
-          <ac:chgData name="Fatima Pillosu" userId="a6295d4dc9e22643" providerId="LiveId" clId="{E0DE9FFC-A79A-49F3-A9EA-98D7366CA706}" dt="2025-05-24T17:49:35.810" v="1276"/>
-          <ac:picMkLst>
-            <pc:docMk/>
-            <pc:sldMk cId="2001934226" sldId="256"/>
-            <ac:picMk id="4" creationId="{88D99402-A6F8-6200-075A-3580037CFB63}"/>
-          </ac:picMkLst>
-        </pc:picChg>
-        <pc:picChg chg="add mod">
-          <ac:chgData name="Fatima Pillosu" userId="a6295d4dc9e22643" providerId="LiveId" clId="{E0DE9FFC-A79A-49F3-A9EA-98D7366CA706}" dt="2025-05-24T17:49:35.810" v="1276"/>
-          <ac:picMkLst>
-            <pc:docMk/>
-            <pc:sldMk cId="2001934226" sldId="256"/>
-            <ac:picMk id="5" creationId="{418065AA-8313-1CC2-5EE1-9C56B8E0F973}"/>
-          </ac:picMkLst>
-        </pc:picChg>
-        <pc:picChg chg="add del mod modCrop">
-          <ac:chgData name="Fatima Pillosu" userId="a6295d4dc9e22643" providerId="LiveId" clId="{E0DE9FFC-A79A-49F3-A9EA-98D7366CA706}" dt="2025-05-24T16:28:51.933" v="575" actId="478"/>
-          <ac:picMkLst>
-            <pc:docMk/>
-            <pc:sldMk cId="2001934226" sldId="256"/>
-            <ac:picMk id="5" creationId="{87F9BF24-68CF-2FA5-E7E5-099E33460BC3}"/>
-          </ac:picMkLst>
-        </pc:picChg>
-        <pc:picChg chg="add del mod ord modCrop">
-          <ac:chgData name="Fatima Pillosu" userId="a6295d4dc9e22643" providerId="LiveId" clId="{E0DE9FFC-A79A-49F3-A9EA-98D7366CA706}" dt="2025-05-24T17:49:23.420" v="1275" actId="21"/>
-          <ac:picMkLst>
-            <pc:docMk/>
-            <pc:sldMk cId="2001934226" sldId="256"/>
-            <ac:picMk id="6" creationId="{88D99402-A6F8-6200-075A-3580037CFB63}"/>
-          </ac:picMkLst>
-        </pc:picChg>
-        <pc:picChg chg="add del mod ord modCrop">
-          <ac:chgData name="Fatima Pillosu" userId="a6295d4dc9e22643" providerId="LiveId" clId="{E0DE9FFC-A79A-49F3-A9EA-98D7366CA706}" dt="2025-05-24T17:49:23.420" v="1275" actId="21"/>
-          <ac:picMkLst>
-            <pc:docMk/>
-            <pc:sldMk cId="2001934226" sldId="256"/>
-            <ac:picMk id="7" creationId="{418065AA-8313-1CC2-5EE1-9C56B8E0F973}"/>
-          </ac:picMkLst>
-        </pc:picChg>
-        <pc:picChg chg="del">
-          <ac:chgData name="Fatima Pillosu" userId="a6295d4dc9e22643" providerId="LiveId" clId="{E0DE9FFC-A79A-49F3-A9EA-98D7366CA706}" dt="2025-05-22T22:26:54.566" v="5" actId="478"/>
-          <ac:picMkLst>
-            <pc:docMk/>
-            <pc:sldMk cId="2001934226" sldId="256"/>
-            <ac:picMk id="7" creationId="{7EFF7F77-577C-D155-E720-34AB428482F6}"/>
-          </ac:picMkLst>
-        </pc:picChg>
-        <pc:picChg chg="add mod">
-          <ac:chgData name="Fatima Pillosu" userId="a6295d4dc9e22643" providerId="LiveId" clId="{E0DE9FFC-A79A-49F3-A9EA-98D7366CA706}" dt="2025-05-24T17:49:35.810" v="1276"/>
-          <ac:picMkLst>
-            <pc:docMk/>
-            <pc:sldMk cId="2001934226" sldId="256"/>
-            <ac:picMk id="8" creationId="{456425BC-5DD3-60EE-62D5-E50A05758999}"/>
-          </ac:picMkLst>
-        </pc:picChg>
-        <pc:picChg chg="add del mod modCrop">
-          <ac:chgData name="Fatima Pillosu" userId="a6295d4dc9e22643" providerId="LiveId" clId="{E0DE9FFC-A79A-49F3-A9EA-98D7366CA706}" dt="2025-05-24T16:28:53.094" v="577" actId="478"/>
-          <ac:picMkLst>
-            <pc:docMk/>
-            <pc:sldMk cId="2001934226" sldId="256"/>
-            <ac:picMk id="8" creationId="{966DFB7E-2313-E3AE-0C7B-A9197A362F8F}"/>
-          </ac:picMkLst>
-        </pc:picChg>
-        <pc:picChg chg="add del mod ord modCrop">
-          <ac:chgData name="Fatima Pillosu" userId="a6295d4dc9e22643" providerId="LiveId" clId="{E0DE9FFC-A79A-49F3-A9EA-98D7366CA706}" dt="2025-05-24T17:49:23.420" v="1275" actId="21"/>
-          <ac:picMkLst>
-            <pc:docMk/>
-            <pc:sldMk cId="2001934226" sldId="256"/>
-            <ac:picMk id="9" creationId="{456425BC-5DD3-60EE-62D5-E50A05758999}"/>
-          </ac:picMkLst>
-        </pc:picChg>
-        <pc:picChg chg="add del mod modCrop">
-          <ac:chgData name="Fatima Pillosu" userId="a6295d4dc9e22643" providerId="LiveId" clId="{E0DE9FFC-A79A-49F3-A9EA-98D7366CA706}" dt="2025-05-24T16:28:52.554" v="576" actId="478"/>
-          <ac:picMkLst>
-            <pc:docMk/>
-            <pc:sldMk cId="2001934226" sldId="256"/>
-            <ac:picMk id="10" creationId="{D642F5E9-932F-B2FC-9F18-0B5575E535D4}"/>
-          </ac:picMkLst>
-        </pc:picChg>
-        <pc:picChg chg="del">
-          <ac:chgData name="Fatima Pillosu" userId="a6295d4dc9e22643" providerId="LiveId" clId="{E0DE9FFC-A79A-49F3-A9EA-98D7366CA706}" dt="2025-05-22T22:26:50.126" v="0" actId="478"/>
-          <ac:picMkLst>
-            <pc:docMk/>
-            <pc:sldMk cId="2001934226" sldId="256"/>
-            <ac:picMk id="11" creationId="{706AFC1D-A936-2CE0-E5A9-873BCA840FB1}"/>
-          </ac:picMkLst>
-        </pc:picChg>
-        <pc:picChg chg="add del mod ord modCrop">
-          <ac:chgData name="Fatima Pillosu" userId="a6295d4dc9e22643" providerId="LiveId" clId="{E0DE9FFC-A79A-49F3-A9EA-98D7366CA706}" dt="2025-05-24T17:49:23.420" v="1275" actId="21"/>
-          <ac:picMkLst>
-            <pc:docMk/>
-            <pc:sldMk cId="2001934226" sldId="256"/>
-            <ac:picMk id="12" creationId="{364666C4-F3CA-09A7-7F4A-4F7FA0193F5F}"/>
-          </ac:picMkLst>
-        </pc:picChg>
-        <pc:picChg chg="add del mod modCrop">
-          <ac:chgData name="Fatima Pillosu" userId="a6295d4dc9e22643" providerId="LiveId" clId="{E0DE9FFC-A79A-49F3-A9EA-98D7366CA706}" dt="2025-05-24T16:28:53.666" v="578" actId="478"/>
-          <ac:picMkLst>
-            <pc:docMk/>
-            <pc:sldMk cId="2001934226" sldId="256"/>
-            <ac:picMk id="13" creationId="{ED4199B9-5924-0506-BBF8-75CD667A48EF}"/>
-          </ac:picMkLst>
-        </pc:picChg>
-        <pc:picChg chg="del">
-          <ac:chgData name="Fatima Pillosu" userId="a6295d4dc9e22643" providerId="LiveId" clId="{E0DE9FFC-A79A-49F3-A9EA-98D7366CA706}" dt="2025-05-22T22:26:51.046" v="2" actId="478"/>
-          <ac:picMkLst>
-            <pc:docMk/>
-            <pc:sldMk cId="2001934226" sldId="256"/>
-            <ac:picMk id="15" creationId="{C59B432D-0D81-1D00-E1A2-EFBF8B1B92EC}"/>
-          </ac:picMkLst>
-        </pc:picChg>
-        <pc:picChg chg="add del mod ord modCrop">
-          <ac:chgData name="Fatima Pillosu" userId="a6295d4dc9e22643" providerId="LiveId" clId="{E0DE9FFC-A79A-49F3-A9EA-98D7366CA706}" dt="2025-05-24T17:49:23.420" v="1275" actId="21"/>
-          <ac:picMkLst>
-            <pc:docMk/>
-            <pc:sldMk cId="2001934226" sldId="256"/>
-            <ac:picMk id="15" creationId="{F8264153-7720-42A1-AED4-320543208D7A}"/>
-          </ac:picMkLst>
-        </pc:picChg>
-        <pc:picChg chg="add del mod modCrop">
-          <ac:chgData name="Fatima Pillosu" userId="a6295d4dc9e22643" providerId="LiveId" clId="{E0DE9FFC-A79A-49F3-A9EA-98D7366CA706}" dt="2025-05-24T16:28:54.158" v="579" actId="478"/>
-          <ac:picMkLst>
-            <pc:docMk/>
-            <pc:sldMk cId="2001934226" sldId="256"/>
-            <ac:picMk id="16" creationId="{B66B38DB-221B-0B21-B782-2A24DDDA85FD}"/>
-          </ac:picMkLst>
-        </pc:picChg>
-        <pc:picChg chg="del">
-          <ac:chgData name="Fatima Pillosu" userId="a6295d4dc9e22643" providerId="LiveId" clId="{E0DE9FFC-A79A-49F3-A9EA-98D7366CA706}" dt="2025-05-22T22:26:50.613" v="1" actId="478"/>
-          <ac:picMkLst>
-            <pc:docMk/>
-            <pc:sldMk cId="2001934226" sldId="256"/>
-            <ac:picMk id="19" creationId="{2A46B08F-D5EF-8DA6-EE9C-D7579C9F85A6}"/>
-          </ac:picMkLst>
-        </pc:picChg>
-        <pc:picChg chg="add del mod ord modCrop">
-          <ac:chgData name="Fatima Pillosu" userId="a6295d4dc9e22643" providerId="LiveId" clId="{E0DE9FFC-A79A-49F3-A9EA-98D7366CA706}" dt="2025-05-24T17:49:23.420" v="1275" actId="21"/>
-          <ac:picMkLst>
-            <pc:docMk/>
-            <pc:sldMk cId="2001934226" sldId="256"/>
-            <ac:picMk id="20" creationId="{60C6E82B-7081-61AF-D5FA-746E2FCF6AF4}"/>
-          </ac:picMkLst>
-        </pc:picChg>
-        <pc:picChg chg="add mod">
-          <ac:chgData name="Fatima Pillosu" userId="a6295d4dc9e22643" providerId="LiveId" clId="{E0DE9FFC-A79A-49F3-A9EA-98D7366CA706}" dt="2025-05-24T17:49:35.810" v="1276"/>
-          <ac:picMkLst>
-            <pc:docMk/>
-            <pc:sldMk cId="2001934226" sldId="256"/>
-            <ac:picMk id="21" creationId="{364666C4-F3CA-09A7-7F4A-4F7FA0193F5F}"/>
-          </ac:picMkLst>
-        </pc:picChg>
-        <pc:picChg chg="add mod">
-          <ac:chgData name="Fatima Pillosu" userId="a6295d4dc9e22643" providerId="LiveId" clId="{E0DE9FFC-A79A-49F3-A9EA-98D7366CA706}" dt="2025-05-24T17:49:35.810" v="1276"/>
-          <ac:picMkLst>
-            <pc:docMk/>
-            <pc:sldMk cId="2001934226" sldId="256"/>
-            <ac:picMk id="22" creationId="{F8264153-7720-42A1-AED4-320543208D7A}"/>
-          </ac:picMkLst>
-        </pc:picChg>
-        <pc:picChg chg="add mod">
-          <ac:chgData name="Fatima Pillosu" userId="a6295d4dc9e22643" providerId="LiveId" clId="{E0DE9FFC-A79A-49F3-A9EA-98D7366CA706}" dt="2025-05-24T17:49:35.810" v="1276"/>
-          <ac:picMkLst>
-            <pc:docMk/>
-            <pc:sldMk cId="2001934226" sldId="256"/>
-            <ac:picMk id="23" creationId="{60C6E82B-7081-61AF-D5FA-746E2FCF6AF4}"/>
-          </ac:picMkLst>
-        </pc:picChg>
-        <pc:picChg chg="del">
-          <ac:chgData name="Fatima Pillosu" userId="a6295d4dc9e22643" providerId="LiveId" clId="{E0DE9FFC-A79A-49F3-A9EA-98D7366CA706}" dt="2025-05-22T22:26:51.503" v="3" actId="478"/>
-          <ac:picMkLst>
-            <pc:docMk/>
-            <pc:sldMk cId="2001934226" sldId="256"/>
-            <ac:picMk id="27" creationId="{9D6E1EF4-9418-2978-80FC-CA73F4A4E278}"/>
-          </ac:picMkLst>
-        </pc:picChg>
-        <pc:picChg chg="del">
-          <ac:chgData name="Fatima Pillosu" userId="a6295d4dc9e22643" providerId="LiveId" clId="{E0DE9FFC-A79A-49F3-A9EA-98D7366CA706}" dt="2025-05-22T22:26:51.956" v="4" actId="478"/>
-          <ac:picMkLst>
-            <pc:docMk/>
-            <pc:sldMk cId="2001934226" sldId="256"/>
-            <ac:picMk id="31" creationId="{B5A40F9E-D06D-BAAD-8AC4-62AA22C0C9FE}"/>
-          </ac:picMkLst>
-        </pc:picChg>
-        <pc:cxnChg chg="add del mod">
-          <ac:chgData name="Fatima Pillosu" userId="a6295d4dc9e22643" providerId="LiveId" clId="{E0DE9FFC-A79A-49F3-A9EA-98D7366CA706}" dt="2025-05-24T17:49:23.420" v="1275" actId="21"/>
-          <ac:cxnSpMkLst>
-            <pc:docMk/>
-            <pc:sldMk cId="2001934226" sldId="256"/>
-            <ac:cxnSpMk id="32" creationId="{A10F3755-65FA-8268-88B6-1CBC42EFB7F8}"/>
-          </ac:cxnSpMkLst>
-        </pc:cxnChg>
-        <pc:cxnChg chg="add mod">
-          <ac:chgData name="Fatima Pillosu" userId="a6295d4dc9e22643" providerId="LiveId" clId="{E0DE9FFC-A79A-49F3-A9EA-98D7366CA706}" dt="2025-05-24T17:49:45.139" v="1294" actId="1037"/>
-          <ac:cxnSpMkLst>
-            <pc:docMk/>
-            <pc:sldMk cId="2001934226" sldId="256"/>
-            <ac:cxnSpMk id="47" creationId="{A10F3755-65FA-8268-88B6-1CBC42EFB7F8}"/>
-          </ac:cxnSpMkLst>
-        </pc:cxnChg>
-      </pc:sldChg>
-      <pc:sldChg chg="addSp delSp modSp add del mod">
-        <pc:chgData name="Fatima Pillosu" userId="a6295d4dc9e22643" providerId="LiveId" clId="{E0DE9FFC-A79A-49F3-A9EA-98D7366CA706}" dt="2025-05-24T16:40:37.264" v="801" actId="47"/>
-        <pc:sldMkLst>
-          <pc:docMk/>
-          <pc:sldMk cId="920401732" sldId="257"/>
-        </pc:sldMkLst>
-        <pc:spChg chg="del">
-          <ac:chgData name="Fatima Pillosu" userId="a6295d4dc9e22643" providerId="LiveId" clId="{E0DE9FFC-A79A-49F3-A9EA-98D7366CA706}" dt="2025-05-24T16:33:30.296" v="694" actId="478"/>
-          <ac:spMkLst>
-            <pc:docMk/>
-            <pc:sldMk cId="920401732" sldId="257"/>
-            <ac:spMk id="17" creationId="{7D251682-B46D-DC7E-8C5E-59DFF1C27261}"/>
-          </ac:spMkLst>
-        </pc:spChg>
-        <pc:spChg chg="del">
-          <ac:chgData name="Fatima Pillosu" userId="a6295d4dc9e22643" providerId="LiveId" clId="{E0DE9FFC-A79A-49F3-A9EA-98D7366CA706}" dt="2025-05-24T16:33:30.296" v="694" actId="478"/>
-          <ac:spMkLst>
-            <pc:docMk/>
-            <pc:sldMk cId="920401732" sldId="257"/>
-            <ac:spMk id="18" creationId="{18F79773-A305-6943-D6AB-6A9BB374B2B4}"/>
-          </ac:spMkLst>
-        </pc:spChg>
-        <pc:spChg chg="del">
-          <ac:chgData name="Fatima Pillosu" userId="a6295d4dc9e22643" providerId="LiveId" clId="{E0DE9FFC-A79A-49F3-A9EA-98D7366CA706}" dt="2025-05-24T16:33:30.296" v="694" actId="478"/>
-          <ac:spMkLst>
-            <pc:docMk/>
-            <pc:sldMk cId="920401732" sldId="257"/>
-            <ac:spMk id="21" creationId="{0284A2DC-04F5-0D2C-8A57-01740B49A0AD}"/>
-          </ac:spMkLst>
-        </pc:spChg>
-        <pc:spChg chg="del">
-          <ac:chgData name="Fatima Pillosu" userId="a6295d4dc9e22643" providerId="LiveId" clId="{E0DE9FFC-A79A-49F3-A9EA-98D7366CA706}" dt="2025-05-24T16:33:30.296" v="694" actId="478"/>
-          <ac:spMkLst>
-            <pc:docMk/>
-            <pc:sldMk cId="920401732" sldId="257"/>
-            <ac:spMk id="22" creationId="{7792FD3C-224E-D659-A131-B255E8E96E52}"/>
-          </ac:spMkLst>
-        </pc:spChg>
-        <pc:spChg chg="del">
-          <ac:chgData name="Fatima Pillosu" userId="a6295d4dc9e22643" providerId="LiveId" clId="{E0DE9FFC-A79A-49F3-A9EA-98D7366CA706}" dt="2025-05-24T16:33:30.296" v="694" actId="478"/>
-          <ac:spMkLst>
-            <pc:docMk/>
-            <pc:sldMk cId="920401732" sldId="257"/>
-            <ac:spMk id="23" creationId="{F19462D0-2710-AA91-1CCF-483BA08755F9}"/>
-          </ac:spMkLst>
-        </pc:spChg>
-        <pc:spChg chg="del">
-          <ac:chgData name="Fatima Pillosu" userId="a6295d4dc9e22643" providerId="LiveId" clId="{E0DE9FFC-A79A-49F3-A9EA-98D7366CA706}" dt="2025-05-24T16:33:30.296" v="694" actId="478"/>
-          <ac:spMkLst>
-            <pc:docMk/>
-            <pc:sldMk cId="920401732" sldId="257"/>
-            <ac:spMk id="24" creationId="{728394F9-CAEC-DD34-1C7D-BCD4BEC3F436}"/>
-          </ac:spMkLst>
-        </pc:spChg>
-        <pc:spChg chg="del">
-          <ac:chgData name="Fatima Pillosu" userId="a6295d4dc9e22643" providerId="LiveId" clId="{E0DE9FFC-A79A-49F3-A9EA-98D7366CA706}" dt="2025-05-24T16:33:30.296" v="694" actId="478"/>
-          <ac:spMkLst>
-            <pc:docMk/>
-            <pc:sldMk cId="920401732" sldId="257"/>
-            <ac:spMk id="25" creationId="{FC832C13-787F-2152-898E-AA680DE9C99E}"/>
-          </ac:spMkLst>
-        </pc:spChg>
-        <pc:picChg chg="del">
-          <ac:chgData name="Fatima Pillosu" userId="a6295d4dc9e22643" providerId="LiveId" clId="{E0DE9FFC-A79A-49F3-A9EA-98D7366CA706}" dt="2025-05-24T16:33:30.296" v="694" actId="478"/>
-          <ac:picMkLst>
-            <pc:docMk/>
-            <pc:sldMk cId="920401732" sldId="257"/>
-            <ac:picMk id="3" creationId="{654FB377-4601-2239-3475-0294C0DABA0E}"/>
-          </ac:picMkLst>
-        </pc:picChg>
-        <pc:picChg chg="add del mod modCrop">
-          <ac:chgData name="Fatima Pillosu" userId="a6295d4dc9e22643" providerId="LiveId" clId="{E0DE9FFC-A79A-49F3-A9EA-98D7366CA706}" dt="2025-05-24T16:35:54.312" v="737" actId="21"/>
-          <ac:picMkLst>
-            <pc:docMk/>
-            <pc:sldMk cId="920401732" sldId="257"/>
-            <ac:picMk id="4" creationId="{88D99402-A6F8-6200-075A-3580037CFB63}"/>
-          </ac:picMkLst>
-        </pc:picChg>
-        <pc:picChg chg="del">
-          <ac:chgData name="Fatima Pillosu" userId="a6295d4dc9e22643" providerId="LiveId" clId="{E0DE9FFC-A79A-49F3-A9EA-98D7366CA706}" dt="2025-05-24T16:33:30.296" v="694" actId="478"/>
-          <ac:picMkLst>
-            <pc:docMk/>
-            <pc:sldMk cId="920401732" sldId="257"/>
-            <ac:picMk id="5" creationId="{87F9BF24-68CF-2FA5-E7E5-099E33460BC3}"/>
-          </ac:picMkLst>
-        </pc:picChg>
-        <pc:picChg chg="add del mod modCrop">
-          <ac:chgData name="Fatima Pillosu" userId="a6295d4dc9e22643" providerId="LiveId" clId="{E0DE9FFC-A79A-49F3-A9EA-98D7366CA706}" dt="2025-05-24T16:35:54.312" v="737" actId="21"/>
-          <ac:picMkLst>
-            <pc:docMk/>
-            <pc:sldMk cId="920401732" sldId="257"/>
-            <ac:picMk id="6" creationId="{418065AA-8313-1CC2-5EE1-9C56B8E0F973}"/>
-          </ac:picMkLst>
-        </pc:picChg>
-        <pc:picChg chg="del">
-          <ac:chgData name="Fatima Pillosu" userId="a6295d4dc9e22643" providerId="LiveId" clId="{E0DE9FFC-A79A-49F3-A9EA-98D7366CA706}" dt="2025-05-24T16:33:30.296" v="694" actId="478"/>
-          <ac:picMkLst>
-            <pc:docMk/>
-            <pc:sldMk cId="920401732" sldId="257"/>
-            <ac:picMk id="8" creationId="{966DFB7E-2313-E3AE-0C7B-A9197A362F8F}"/>
-          </ac:picMkLst>
-        </pc:picChg>
-        <pc:picChg chg="add del mod modCrop">
-          <ac:chgData name="Fatima Pillosu" userId="a6295d4dc9e22643" providerId="LiveId" clId="{E0DE9FFC-A79A-49F3-A9EA-98D7366CA706}" dt="2025-05-24T16:35:54.312" v="737" actId="21"/>
-          <ac:picMkLst>
-            <pc:docMk/>
-            <pc:sldMk cId="920401732" sldId="257"/>
-            <ac:picMk id="9" creationId="{456425BC-5DD3-60EE-62D5-E50A05758999}"/>
-          </ac:picMkLst>
-        </pc:picChg>
-        <pc:picChg chg="del">
-          <ac:chgData name="Fatima Pillosu" userId="a6295d4dc9e22643" providerId="LiveId" clId="{E0DE9FFC-A79A-49F3-A9EA-98D7366CA706}" dt="2025-05-24T16:33:30.296" v="694" actId="478"/>
-          <ac:picMkLst>
-            <pc:docMk/>
-            <pc:sldMk cId="920401732" sldId="257"/>
-            <ac:picMk id="10" creationId="{D642F5E9-932F-B2FC-9F18-0B5575E535D4}"/>
-          </ac:picMkLst>
-        </pc:picChg>
-        <pc:picChg chg="add del mod modCrop">
-          <ac:chgData name="Fatima Pillosu" userId="a6295d4dc9e22643" providerId="LiveId" clId="{E0DE9FFC-A79A-49F3-A9EA-98D7366CA706}" dt="2025-05-24T16:35:54.312" v="737" actId="21"/>
-          <ac:picMkLst>
-            <pc:docMk/>
-            <pc:sldMk cId="920401732" sldId="257"/>
-            <ac:picMk id="12" creationId="{364666C4-F3CA-09A7-7F4A-4F7FA0193F5F}"/>
-          </ac:picMkLst>
-        </pc:picChg>
-        <pc:picChg chg="del">
-          <ac:chgData name="Fatima Pillosu" userId="a6295d4dc9e22643" providerId="LiveId" clId="{E0DE9FFC-A79A-49F3-A9EA-98D7366CA706}" dt="2025-05-24T16:33:30.296" v="694" actId="478"/>
-          <ac:picMkLst>
-            <pc:docMk/>
-            <pc:sldMk cId="920401732" sldId="257"/>
-            <ac:picMk id="13" creationId="{ED4199B9-5924-0506-BBF8-75CD667A48EF}"/>
-          </ac:picMkLst>
-        </pc:picChg>
-        <pc:picChg chg="add del mod modCrop">
-          <ac:chgData name="Fatima Pillosu" userId="a6295d4dc9e22643" providerId="LiveId" clId="{E0DE9FFC-A79A-49F3-A9EA-98D7366CA706}" dt="2025-05-24T16:35:54.312" v="737" actId="21"/>
-          <ac:picMkLst>
-            <pc:docMk/>
-            <pc:sldMk cId="920401732" sldId="257"/>
-            <ac:picMk id="15" creationId="{F8264153-7720-42A1-AED4-320543208D7A}"/>
-          </ac:picMkLst>
-        </pc:picChg>
-        <pc:picChg chg="del">
-          <ac:chgData name="Fatima Pillosu" userId="a6295d4dc9e22643" providerId="LiveId" clId="{E0DE9FFC-A79A-49F3-A9EA-98D7366CA706}" dt="2025-05-24T16:33:30.296" v="694" actId="478"/>
-          <ac:picMkLst>
-            <pc:docMk/>
-            <pc:sldMk cId="920401732" sldId="257"/>
-            <ac:picMk id="16" creationId="{B66B38DB-221B-0B21-B782-2A24DDDA85FD}"/>
-          </ac:picMkLst>
-        </pc:picChg>
-        <pc:picChg chg="add del mod modCrop">
-          <ac:chgData name="Fatima Pillosu" userId="a6295d4dc9e22643" providerId="LiveId" clId="{E0DE9FFC-A79A-49F3-A9EA-98D7366CA706}" dt="2025-05-24T16:35:54.312" v="737" actId="21"/>
-          <ac:picMkLst>
-            <pc:docMk/>
-            <pc:sldMk cId="920401732" sldId="257"/>
-            <ac:picMk id="20" creationId="{60C6E82B-7081-61AF-D5FA-746E2FCF6AF4}"/>
-          </ac:picMkLst>
-        </pc:picChg>
-      </pc:sldChg>
-    </pc:docChg>
-  </pc:docChgLst>
-  <pc:docChgLst>
-    <pc:chgData name="Fatima Pillosu" userId="a6295d4dc9e22643" providerId="LiveId" clId="{E99C33BB-13DC-4F1D-A1BF-B74F8F895F83}"/>
-    <pc:docChg chg="delSld">
-      <pc:chgData name="Fatima Pillosu" userId="a6295d4dc9e22643" providerId="LiveId" clId="{E99C33BB-13DC-4F1D-A1BF-B74F8F895F83}" dt="2025-05-22T22:19:44.013" v="0" actId="2696"/>
-      <pc:docMkLst>
-        <pc:docMk/>
-      </pc:docMkLst>
-      <pc:sldChg chg="del">
-        <pc:chgData name="Fatima Pillosu" userId="a6295d4dc9e22643" providerId="LiveId" clId="{E99C33BB-13DC-4F1D-A1BF-B74F8F895F83}" dt="2025-05-22T22:19:44.013" v="0" actId="2696"/>
-        <pc:sldMkLst>
-          <pc:docMk/>
-          <pc:sldMk cId="2132159043" sldId="257"/>
-        </pc:sldMkLst>
       </pc:sldChg>
     </pc:docChg>
   </pc:docChgLst>
@@ -999,7 +320,7 @@
           <a:p>
             <a:fld id="{4F89630D-F1D9-4981-8FD4-E20F703F26B8}" type="datetimeFigureOut">
               <a:rPr lang="en-GB" smtClean="0"/>
-              <a:t>24/05/2025</a:t>
+              <a:t>26/01/2026</a:t>
             </a:fld>
             <a:endParaRPr lang="en-GB"/>
           </a:p>
@@ -1169,7 +490,7 @@
           <a:p>
             <a:fld id="{4F89630D-F1D9-4981-8FD4-E20F703F26B8}" type="datetimeFigureOut">
               <a:rPr lang="en-GB" smtClean="0"/>
-              <a:t>24/05/2025</a:t>
+              <a:t>26/01/2026</a:t>
             </a:fld>
             <a:endParaRPr lang="en-GB"/>
           </a:p>
@@ -1349,7 +670,7 @@
           <a:p>
             <a:fld id="{4F89630D-F1D9-4981-8FD4-E20F703F26B8}" type="datetimeFigureOut">
               <a:rPr lang="en-GB" smtClean="0"/>
-              <a:t>24/05/2025</a:t>
+              <a:t>26/01/2026</a:t>
             </a:fld>
             <a:endParaRPr lang="en-GB"/>
           </a:p>
@@ -1519,7 +840,7 @@
           <a:p>
             <a:fld id="{4F89630D-F1D9-4981-8FD4-E20F703F26B8}" type="datetimeFigureOut">
               <a:rPr lang="en-GB" smtClean="0"/>
-              <a:t>24/05/2025</a:t>
+              <a:t>26/01/2026</a:t>
             </a:fld>
             <a:endParaRPr lang="en-GB"/>
           </a:p>
@@ -1765,7 +1086,7 @@
           <a:p>
             <a:fld id="{4F89630D-F1D9-4981-8FD4-E20F703F26B8}" type="datetimeFigureOut">
               <a:rPr lang="en-GB" smtClean="0"/>
-              <a:t>24/05/2025</a:t>
+              <a:t>26/01/2026</a:t>
             </a:fld>
             <a:endParaRPr lang="en-GB"/>
           </a:p>
@@ -1997,7 +1318,7 @@
           <a:p>
             <a:fld id="{4F89630D-F1D9-4981-8FD4-E20F703F26B8}" type="datetimeFigureOut">
               <a:rPr lang="en-GB" smtClean="0"/>
-              <a:t>24/05/2025</a:t>
+              <a:t>26/01/2026</a:t>
             </a:fld>
             <a:endParaRPr lang="en-GB"/>
           </a:p>
@@ -2364,7 +1685,7 @@
           <a:p>
             <a:fld id="{4F89630D-F1D9-4981-8FD4-E20F703F26B8}" type="datetimeFigureOut">
               <a:rPr lang="en-GB" smtClean="0"/>
-              <a:t>24/05/2025</a:t>
+              <a:t>26/01/2026</a:t>
             </a:fld>
             <a:endParaRPr lang="en-GB"/>
           </a:p>
@@ -2482,7 +1803,7 @@
           <a:p>
             <a:fld id="{4F89630D-F1D9-4981-8FD4-E20F703F26B8}" type="datetimeFigureOut">
               <a:rPr lang="en-GB" smtClean="0"/>
-              <a:t>24/05/2025</a:t>
+              <a:t>26/01/2026</a:t>
             </a:fld>
             <a:endParaRPr lang="en-GB"/>
           </a:p>
@@ -2577,7 +1898,7 @@
           <a:p>
             <a:fld id="{4F89630D-F1D9-4981-8FD4-E20F703F26B8}" type="datetimeFigureOut">
               <a:rPr lang="en-GB" smtClean="0"/>
-              <a:t>24/05/2025</a:t>
+              <a:t>26/01/2026</a:t>
             </a:fld>
             <a:endParaRPr lang="en-GB"/>
           </a:p>
@@ -2854,7 +2175,7 @@
           <a:p>
             <a:fld id="{4F89630D-F1D9-4981-8FD4-E20F703F26B8}" type="datetimeFigureOut">
               <a:rPr lang="en-GB" smtClean="0"/>
-              <a:t>24/05/2025</a:t>
+              <a:t>26/01/2026</a:t>
             </a:fld>
             <a:endParaRPr lang="en-GB"/>
           </a:p>
@@ -3111,7 +2432,7 @@
           <a:p>
             <a:fld id="{4F89630D-F1D9-4981-8FD4-E20F703F26B8}" type="datetimeFigureOut">
               <a:rPr lang="en-GB" smtClean="0"/>
-              <a:t>24/05/2025</a:t>
+              <a:t>26/01/2026</a:t>
             </a:fld>
             <a:endParaRPr lang="en-GB"/>
           </a:p>
@@ -3324,7 +2645,7 @@
           <a:p>
             <a:fld id="{4F89630D-F1D9-4981-8FD4-E20F703F26B8}" type="datetimeFigureOut">
               <a:rPr lang="en-GB" smtClean="0"/>
-              <a:t>24/05/2025</a:t>
+              <a:t>26/01/2026</a:t>
             </a:fld>
             <a:endParaRPr lang="en-GB"/>
           </a:p>
@@ -4035,8 +3356,8 @@
         </p:nvSpPr>
         <p:spPr>
           <a:xfrm>
-            <a:off x="1043940" y="1996544"/>
-            <a:ext cx="786840" cy="338554"/>
+            <a:off x="866094" y="2042724"/>
+            <a:ext cx="964686" cy="338554"/>
           </a:xfrm>
           <a:prstGeom prst="rect">
             <a:avLst/>
@@ -4068,7 +3389,7 @@
                 <a:latin typeface="Calibri Light" panose="020F0302020204030204" pitchFamily="34" charset="0"/>
                 <a:cs typeface="Calibri Light" panose="020F0302020204030204" pitchFamily="34" charset="0"/>
               </a:rPr>
-              <a:t>AROC = 0.675</a:t>
+              <a:t>AUC-ROC = 0.675</a:t>
             </a:r>
           </a:p>
           <a:p>
@@ -4160,8 +3481,8 @@
         </p:nvSpPr>
         <p:spPr>
           <a:xfrm>
-            <a:off x="2828682" y="1996544"/>
-            <a:ext cx="786840" cy="338554"/>
+            <a:off x="2650836" y="2042724"/>
+            <a:ext cx="964686" cy="338554"/>
           </a:xfrm>
           <a:prstGeom prst="rect">
             <a:avLst/>
@@ -4193,7 +3514,7 @@
                 <a:latin typeface="Calibri Light" panose="020F0302020204030204" pitchFamily="34" charset="0"/>
                 <a:cs typeface="Calibri Light" panose="020F0302020204030204" pitchFamily="34" charset="0"/>
               </a:rPr>
-              <a:t>AROC = 0.692</a:t>
+              <a:t>AUC-ROC = 0.692</a:t>
             </a:r>
           </a:p>
           <a:p>
@@ -4228,8 +3549,8 @@
         </p:nvSpPr>
         <p:spPr>
           <a:xfrm>
-            <a:off x="1043940" y="3924404"/>
-            <a:ext cx="786840" cy="338554"/>
+            <a:off x="866094" y="3970584"/>
+            <a:ext cx="964686" cy="338554"/>
           </a:xfrm>
           <a:prstGeom prst="rect">
             <a:avLst/>
@@ -4261,7 +3582,7 @@
                 <a:latin typeface="Calibri Light" panose="020F0302020204030204" pitchFamily="34" charset="0"/>
                 <a:cs typeface="Calibri Light" panose="020F0302020204030204" pitchFamily="34" charset="0"/>
               </a:rPr>
-              <a:t>AROC = 0.655</a:t>
+              <a:t>AUC-ROC = 0.655</a:t>
             </a:r>
           </a:p>
           <a:p>
@@ -4296,8 +3617,8 @@
         </p:nvSpPr>
         <p:spPr>
           <a:xfrm>
-            <a:off x="2828682" y="3924404"/>
-            <a:ext cx="786840" cy="338554"/>
+            <a:off x="2650836" y="3970584"/>
+            <a:ext cx="964686" cy="338554"/>
           </a:xfrm>
           <a:prstGeom prst="rect">
             <a:avLst/>
@@ -4329,7 +3650,7 @@
                 <a:latin typeface="Calibri Light" panose="020F0302020204030204" pitchFamily="34" charset="0"/>
                 <a:cs typeface="Calibri Light" panose="020F0302020204030204" pitchFamily="34" charset="0"/>
               </a:rPr>
-              <a:t>AROC = 0.634</a:t>
+              <a:t>AUC-ROC = 0.634</a:t>
             </a:r>
           </a:p>
           <a:p>
@@ -4364,8 +3685,8 @@
         </p:nvSpPr>
         <p:spPr>
           <a:xfrm>
-            <a:off x="1043940" y="5871314"/>
-            <a:ext cx="786840" cy="338554"/>
+            <a:off x="866094" y="5917494"/>
+            <a:ext cx="964686" cy="338554"/>
           </a:xfrm>
           <a:prstGeom prst="rect">
             <a:avLst/>
@@ -4397,7 +3718,7 @@
                 <a:latin typeface="Calibri Light" panose="020F0302020204030204" pitchFamily="34" charset="0"/>
                 <a:cs typeface="Calibri Light" panose="020F0302020204030204" pitchFamily="34" charset="0"/>
               </a:rPr>
-              <a:t>AROC = 0.623</a:t>
+              <a:t>AUC-ROC = 0.623</a:t>
             </a:r>
           </a:p>
           <a:p>
@@ -4432,8 +3753,8 @@
         </p:nvSpPr>
         <p:spPr>
           <a:xfrm>
-            <a:off x="2828682" y="5871314"/>
-            <a:ext cx="786840" cy="338554"/>
+            <a:off x="2650836" y="5917494"/>
+            <a:ext cx="964686" cy="338554"/>
           </a:xfrm>
           <a:prstGeom prst="rect">
             <a:avLst/>
@@ -4465,7 +3786,7 @@
                 <a:latin typeface="Calibri Light" panose="020F0302020204030204" pitchFamily="34" charset="0"/>
                 <a:cs typeface="Calibri Light" panose="020F0302020204030204" pitchFamily="34" charset="0"/>
               </a:rPr>
-              <a:t>AROC = 0.612</a:t>
+              <a:t>AUC-ROC = 0.612</a:t>
             </a:r>
           </a:p>
           <a:p>

</xml_diff>